<commit_message>
docs: single demo link on presentation slide 4
Co-Authored-By: Claude Sonnet 5.5 <noreply@anthropic.com>
Claude-Session: https://claude.ai/code/session_01Y5U78NTNQD6k3vYT9fZVDm
</commit_message>
<xml_diff>
--- a/docs/hackathon/OpenTutor_in_5_slides.pptx
+++ b/docs/hackathon/OpenTutor_in_5_slides.pptx
@@ -3570,53 +3570,6 @@
               <a:t>Watch the demo on YouTube</a:t>
             </a:r>
             <a:endParaRPr lang="en-US" sz="2000" dirty="0"/>
-          </a:p>
-        </p:txBody>
-      </p:sp>
-      <p:sp>
-        <p:nvSpPr>
-          <p:cNvPr id="9" name="Text 6">
-            <a:hlinkClick r:id="rId4"/>
-          </p:cNvPr>
-          <p:cNvSpPr/>
-          <p:nvPr/>
-        </p:nvSpPr>
-        <p:spPr>
-          <a:xfrm>
-            <a:off x="812800" y="5069880"/>
-            <a:ext cx="6540500" cy="327620"/>
-          </a:xfrm>
-          <a:prstGeom prst="rect">
-            <a:avLst/>
-          </a:prstGeom>
-          <a:noFill/>
-          <a:ln/>
-        </p:spPr>
-        <p:txBody>
-          <a:bodyPr wrap="square" lIns="0" tIns="0" rIns="0" bIns="0" rtlCol="0" anchor="t">
-            <a:normAutofit/>
-          </a:bodyPr>
-          <a:lstStyle/>
-          <a:p>
-            <a:pPr algn="l" indent="0" marL="0">
-              <a:lnSpc>
-                <a:spcPts val="2380"/>
-              </a:lnSpc>
-              <a:buNone/>
-            </a:pPr>
-            <a:r>
-              <a:rPr lang="en-US" sz="1700" dirty="0">
-                <a:solidFill>
-                  <a:srgbClr val="F4EFE5"/>
-                </a:solidFill>
-                <a:latin typeface="Public Sans" pitchFamily="34" charset="0"/>
-                <a:ea typeface="Public Sans" pitchFamily="34" charset="-122"/>
-                <a:cs typeface="Public Sans" pitchFamily="34" charset="-120"/>
-                <a:hlinkClick r:id="rId4"/>
-              </a:rPr>
-              <a:t>youtu.be/syDQ9Jdgxro</a:t>
-            </a:r>
-            <a:endParaRPr lang="en-US" sz="1700" dirty="0"/>
           </a:p>
         </p:txBody>
       </p:sp>

</xml_diff>